<commit_message>
Updates to Observer slides
</commit_message>
<xml_diff>
--- a/03 Observer/GoF Observer.pptx
+++ b/03 Observer/GoF Observer.pptx
@@ -34,7 +34,7 @@
   <p:notesSz cx="6797675" cy="9926638"/>
   <p:embeddedFontLst>
     <p:embeddedFont>
-      <p:font typeface="AU Passata" panose="020B0803030502030804" pitchFamily="34" charset="77"/>
+      <p:font typeface="AU Passata" panose="020B0503030502030804"/>
       <p:regular r:id="rId34"/>
       <p:bold r:id="rId35"/>
     </p:embeddedFont>
@@ -1472,7 +1472,7 @@
             <a:fld id="{78417F83-4CBA-48F2-BAD0-783AE3701E32}" type="datetimeFigureOut">
               <a:rPr lang="en-GB" smtClean="0"/>
               <a:pPr/>
-              <a:t>10/09/2025</a:t>
+              <a:t>08/09/2026</a:t>
             </a:fld>
             <a:endParaRPr lang="en-GB" dirty="0"/>
           </a:p>
@@ -2173,7 +2173,7 @@
             <a:fld id="{78417F83-4CBA-48F2-BAD0-783AE3701E32}" type="datetimeFigureOut">
               <a:rPr lang="en-GB" smtClean="0"/>
               <a:pPr/>
-              <a:t>10/09/2025</a:t>
+              <a:t>08/09/2026</a:t>
             </a:fld>
             <a:endParaRPr lang="en-GB" dirty="0"/>
           </a:p>
@@ -2411,7 +2411,7 @@
             <a:fld id="{78417F83-4CBA-48F2-BAD0-783AE3701E32}" type="datetimeFigureOut">
               <a:rPr lang="en-GB" smtClean="0"/>
               <a:pPr/>
-              <a:t>10/09/2025</a:t>
+              <a:t>08/09/2026</a:t>
             </a:fld>
             <a:endParaRPr lang="en-GB" dirty="0"/>
           </a:p>
@@ -2578,7 +2578,7 @@
             <a:fld id="{78417F83-4CBA-48F2-BAD0-783AE3701E32}" type="datetimeFigureOut">
               <a:rPr lang="en-GB" smtClean="0"/>
               <a:pPr/>
-              <a:t>10/09/2025</a:t>
+              <a:t>08/09/2026</a:t>
             </a:fld>
             <a:endParaRPr lang="en-GB" dirty="0"/>
           </a:p>
@@ -2749,7 +2749,7 @@
             <a:fld id="{78417F83-4CBA-48F2-BAD0-783AE3701E32}" type="datetimeFigureOut">
               <a:rPr lang="en-GB" smtClean="0"/>
               <a:pPr/>
-              <a:t>10/09/2025</a:t>
+              <a:t>08/09/2026</a:t>
             </a:fld>
             <a:endParaRPr lang="en-GB" dirty="0"/>
           </a:p>
@@ -3083,7 +3083,7 @@
             <a:fld id="{78417F83-4CBA-48F2-BAD0-783AE3701E32}" type="datetimeFigureOut">
               <a:rPr lang="en-GB" smtClean="0"/>
               <a:pPr/>
-              <a:t>10/09/2025</a:t>
+              <a:t>08/09/2026</a:t>
             </a:fld>
             <a:endParaRPr lang="en-GB" dirty="0"/>
           </a:p>
@@ -3251,7 +3251,7 @@
             <a:fld id="{78417F83-4CBA-48F2-BAD0-783AE3701E32}" type="datetimeFigureOut">
               <a:rPr lang="en-GB" smtClean="0"/>
               <a:pPr/>
-              <a:t>10/09/2025</a:t>
+              <a:t>08/09/2026</a:t>
             </a:fld>
             <a:endParaRPr lang="en-GB" dirty="0"/>
           </a:p>
@@ -3444,7 +3444,7 @@
             <a:fld id="{78417F83-4CBA-48F2-BAD0-783AE3701E32}" type="datetimeFigureOut">
               <a:rPr lang="en-GB" smtClean="0"/>
               <a:pPr/>
-              <a:t>10/09/2025</a:t>
+              <a:t>08/09/2026</a:t>
             </a:fld>
             <a:endParaRPr lang="en-GB" dirty="0"/>
           </a:p>
@@ -3610,7 +3610,7 @@
             <a:fld id="{78417F83-4CBA-48F2-BAD0-783AE3701E32}" type="datetimeFigureOut">
               <a:rPr lang="en-GB" smtClean="0"/>
               <a:pPr/>
-              <a:t>10/09/2025</a:t>
+              <a:t>08/09/2026</a:t>
             </a:fld>
             <a:endParaRPr lang="en-GB" dirty="0"/>
           </a:p>
@@ -3761,7 +3761,7 @@
             <a:fld id="{78417F83-4CBA-48F2-BAD0-783AE3701E32}" type="datetimeFigureOut">
               <a:rPr lang="en-GB" smtClean="0"/>
               <a:pPr/>
-              <a:t>10/09/2025</a:t>
+              <a:t>08/09/2026</a:t>
             </a:fld>
             <a:endParaRPr lang="en-GB" dirty="0"/>
           </a:p>
@@ -4647,7 +4647,7 @@
             <a:fld id="{78417F83-4CBA-48F2-BAD0-783AE3701E32}" type="datetimeFigureOut">
               <a:rPr lang="en-GB" smtClean="0"/>
               <a:pPr/>
-              <a:t>10/09/2025</a:t>
+              <a:t>08/09/2026</a:t>
             </a:fld>
             <a:endParaRPr lang="en-GB" dirty="0"/>
           </a:p>
@@ -4770,7 +4770,7 @@
             <a:fld id="{78417F83-4CBA-48F2-BAD0-783AE3701E32}" type="datetimeFigureOut">
               <a:rPr lang="en-GB" smtClean="0"/>
               <a:pPr/>
-              <a:t>10/09/2025</a:t>
+              <a:t>08/09/2026</a:t>
             </a:fld>
             <a:endParaRPr lang="en-GB" dirty="0"/>
           </a:p>
@@ -5472,7 +5472,7 @@
             <a:fld id="{78417F83-4CBA-48F2-BAD0-783AE3701E32}" type="datetimeFigureOut">
               <a:rPr lang="en-GB" smtClean="0"/>
               <a:pPr/>
-              <a:t>10/09/2025</a:t>
+              <a:t>08/09/2026</a:t>
             </a:fld>
             <a:endParaRPr lang="en-GB" dirty="0"/>
           </a:p>
@@ -5797,7 +5797,7 @@
             <a:fld id="{78417F83-4CBA-48F2-BAD0-783AE3701E32}" type="datetimeFigureOut">
               <a:rPr lang="en-GB" smtClean="0"/>
               <a:pPr/>
-              <a:t>10/09/2025</a:t>
+              <a:t>08/09/2026</a:t>
             </a:fld>
             <a:endParaRPr lang="en-GB" dirty="0"/>
           </a:p>
@@ -6637,7 +6637,7 @@
             <a:fld id="{78417F83-4CBA-48F2-BAD0-783AE3701E32}" type="datetimeFigureOut">
               <a:rPr lang="en-GB" smtClean="0"/>
               <a:pPr/>
-              <a:t>10/09/2025</a:t>
+              <a:t>08/09/2026</a:t>
             </a:fld>
             <a:endParaRPr lang="en-GB" dirty="0"/>
           </a:p>
@@ -7008,7 +7008,7 @@
             <a:fld id="{78417F83-4CBA-48F2-BAD0-783AE3701E32}" type="datetimeFigureOut">
               <a:rPr lang="en-GB" smtClean="0"/>
               <a:pPr/>
-              <a:t>10/09/2025</a:t>
+              <a:t>08/09/2026</a:t>
             </a:fld>
             <a:endParaRPr lang="en-GB" dirty="0"/>
           </a:p>
@@ -7432,7 +7432,7 @@
             <a:fld id="{78417F83-4CBA-48F2-BAD0-783AE3701E32}" type="datetimeFigureOut">
               <a:rPr lang="en-GB" smtClean="0"/>
               <a:pPr/>
-              <a:t>10/09/2025</a:t>
+              <a:t>08/09/2026</a:t>
             </a:fld>
             <a:endParaRPr lang="en-GB" dirty="0"/>
           </a:p>
@@ -7869,7 +7869,7 @@
             <a:fld id="{78417F83-4CBA-48F2-BAD0-783AE3701E32}" type="datetimeFigureOut">
               <a:rPr lang="en-GB" smtClean="0"/>
               <a:pPr/>
-              <a:t>10/09/2025</a:t>
+              <a:t>08/09/2026</a:t>
             </a:fld>
             <a:endParaRPr lang="en-GB" dirty="0"/>
           </a:p>
@@ -8034,7 +8034,7 @@
             <a:fld id="{78417F83-4CBA-48F2-BAD0-783AE3701E32}" type="datetimeFigureOut">
               <a:rPr lang="en-GB" smtClean="0"/>
               <a:pPr/>
-              <a:t>10/09/2025</a:t>
+              <a:t>08/09/2026</a:t>
             </a:fld>
             <a:endParaRPr lang="en-GB" dirty="0"/>
           </a:p>
@@ -8212,7 +8212,7 @@
             <a:fld id="{78417F83-4CBA-48F2-BAD0-783AE3701E32}" type="datetimeFigureOut">
               <a:rPr lang="en-GB" smtClean="0"/>
               <a:pPr/>
-              <a:t>10/09/2025</a:t>
+              <a:t>08/09/2026</a:t>
             </a:fld>
             <a:endParaRPr lang="en-GB" dirty="0"/>
           </a:p>
@@ -8323,7 +8323,7 @@
             <a:fld id="{78417F83-4CBA-48F2-BAD0-783AE3701E32}" type="datetimeFigureOut">
               <a:rPr lang="en-GB" smtClean="0"/>
               <a:pPr/>
-              <a:t>10/09/2025</a:t>
+              <a:t>08/09/2026</a:t>
             </a:fld>
             <a:endParaRPr lang="en-GB" dirty="0"/>
           </a:p>
@@ -9582,7 +9582,7 @@
           <a:p>
             <a:fld id="{044B90A8-0AE3-8E4B-92D7-0F5B5165B040}" type="datetime1">
               <a:rPr lang="en-GB" smtClean="0"/>
-              <a:t>10/09/2025</a:t>
+              <a:t>08/09/2026</a:t>
             </a:fld>
             <a:endParaRPr lang="en-GB" dirty="0"/>
           </a:p>
@@ -12120,7 +12120,7 @@
           <a:p>
             <a:fld id="{ECCAFF0E-F1C2-0A44-BD86-AD91CF2BCB01}" type="datetime1">
               <a:rPr lang="en-GB" smtClean="0"/>
-              <a:t>10/09/2025</a:t>
+              <a:t>08/09/2026</a:t>
             </a:fld>
             <a:endParaRPr lang="en-GB" dirty="0"/>
           </a:p>
@@ -13966,7 +13966,7 @@
           <a:p>
             <a:fld id="{1364F314-C621-384C-90BA-8C93802D02E7}" type="datetime1">
               <a:rPr lang="en-GB" smtClean="0"/>
-              <a:t>10/09/2025</a:t>
+              <a:t>08/09/2026</a:t>
             </a:fld>
             <a:endParaRPr lang="en-GB" dirty="0"/>
           </a:p>
@@ -15045,7 +15045,7 @@
           <a:p>
             <a:fld id="{846E4A7A-3BB1-1748-AE08-159A20267371}" type="datetime1">
               <a:rPr lang="en-GB" smtClean="0"/>
-              <a:t>10/09/2025</a:t>
+              <a:t>08/09/2026</a:t>
             </a:fld>
             <a:endParaRPr lang="en-GB" dirty="0"/>
           </a:p>
@@ -15857,7 +15857,7 @@
           <a:p>
             <a:fld id="{846E4A7A-3BB1-1748-AE08-159A20267371}" type="datetime1">
               <a:rPr lang="en-GB" smtClean="0"/>
-              <a:t>10/09/2025</a:t>
+              <a:t>08/09/2026</a:t>
             </a:fld>
             <a:endParaRPr lang="en-GB" dirty="0"/>
           </a:p>
@@ -17578,7 +17578,7 @@
           <a:p>
             <a:fld id="{4C6F9505-CEA5-A14A-81DE-35C24F1CA533}" type="datetime1">
               <a:rPr lang="en-GB" smtClean="0"/>
-              <a:t>10/09/2025</a:t>
+              <a:t>08/09/2026</a:t>
             </a:fld>
             <a:endParaRPr lang="en-GB" dirty="0"/>
           </a:p>
@@ -18191,7 +18191,7 @@
           <a:p>
             <a:fld id="{4C6F9505-CEA5-A14A-81DE-35C24F1CA533}" type="datetime1">
               <a:rPr lang="en-GB" smtClean="0"/>
-              <a:t>10/09/2025</a:t>
+              <a:t>08/09/2026</a:t>
             </a:fld>
             <a:endParaRPr lang="en-GB" dirty="0"/>
           </a:p>
@@ -20520,7 +20520,7 @@
           <a:p>
             <a:fld id="{4CC416EC-226B-BE4B-BA12-9D7C2B8C70C7}" type="datetime1">
               <a:rPr lang="en-GB" smtClean="0"/>
-              <a:t>10/09/2025</a:t>
+              <a:t>08/09/2026</a:t>
             </a:fld>
             <a:endParaRPr lang="en-GB" dirty="0"/>
           </a:p>
@@ -20682,7 +20682,7 @@
           <a:p>
             <a:fld id="{EBD85B7D-E9A5-49E0-8ACF-AF93CE3E556F}" type="datetime1">
               <a:rPr lang="en-GB" smtClean="0"/>
-              <a:t>10/09/2025</a:t>
+              <a:t>08/09/2026</a:t>
             </a:fld>
             <a:endParaRPr lang="en-GB" dirty="0"/>
           </a:p>
@@ -21004,7 +21004,7 @@
         <p:spPr bwMode="auto">
           <a:xfrm>
             <a:off x="2199679" y="2492896"/>
-            <a:ext cx="2592388" cy="1033463"/>
+            <a:ext cx="2592388" cy="798765"/>
           </a:xfrm>
           <a:prstGeom prst="rect">
             <a:avLst/>
@@ -21295,28 +21295,28 @@
               </a:spcAft>
             </a:pPr>
             <a:r>
-              <a:rPr lang="en-US" altLang="da-DK" sz="1400" b="1">
+              <a:rPr lang="en-US" altLang="da-DK" sz="1400" b="1" dirty="0">
                 <a:latin typeface="Consolas" panose="020B0609020204030204" pitchFamily="49" charset="0"/>
               </a:rPr>
               <a:t>Provider</a:t>
             </a:r>
             <a:r>
-              <a:rPr lang="en-US" altLang="da-DK" sz="1400"/>
+              <a:rPr lang="en-US" altLang="da-DK" sz="1400" dirty="0"/>
               <a:t> </a:t>
             </a:r>
             <a:r>
-              <a:rPr lang="en-US" altLang="da-DK" sz="1600"/>
+              <a:rPr lang="en-US" altLang="da-DK" sz="1600" dirty="0"/>
               <a:t>contains </a:t>
             </a:r>
             <a:r>
-              <a:rPr lang="en-US" altLang="da-DK" sz="1400">
+              <a:rPr lang="en-US" altLang="da-DK" sz="1400" dirty="0">
                 <a:latin typeface="Consolas" panose="020B0609020204030204" pitchFamily="49" charset="0"/>
               </a:rPr>
               <a:t>data</a:t>
             </a:r>
             <a:r>
-              <a:rPr lang="en-US" altLang="da-DK" sz="1600"/>
-              <a:t> which changes every now and them</a:t>
+              <a:rPr lang="en-US" altLang="da-DK" sz="1600" dirty="0"/>
+              <a:t> which changes over time</a:t>
             </a:r>
           </a:p>
           <a:p>
@@ -21328,7 +21328,7 @@
                 <a:spcPct val="0"/>
               </a:spcAft>
             </a:pPr>
-            <a:endParaRPr lang="en-US" altLang="da-DK" sz="1400"/>
+            <a:endParaRPr lang="en-US" altLang="da-DK" sz="1400" dirty="0"/>
           </a:p>
         </p:txBody>
       </p:sp>
@@ -21349,7 +21349,7 @@
         <p:spPr bwMode="auto">
           <a:xfrm>
             <a:off x="7822604" y="2492896"/>
-            <a:ext cx="2446338" cy="1095375"/>
+            <a:ext cx="2446338" cy="1106542"/>
           </a:xfrm>
           <a:prstGeom prst="rect">
             <a:avLst/>
@@ -21665,7 +21665,7 @@
             </a:r>
             <a:r>
               <a:rPr lang="en-US" altLang="da-DK" sz="1600" dirty="0"/>
-              <a:t>and would like to do some update based on changes in </a:t>
+              <a:t>and would like to do some update based on these changes in </a:t>
             </a:r>
             <a:r>
               <a:rPr lang="en-US" altLang="da-DK" sz="1400" dirty="0">
@@ -22300,7 +22300,7 @@
         </p:nvSpPr>
         <p:spPr>
           <a:xfrm>
-            <a:off x="985838" y="1373021"/>
+            <a:off x="345629" y="1810417"/>
             <a:ext cx="10220325" cy="543811"/>
           </a:xfrm>
         </p:spPr>
@@ -22309,7 +22309,7 @@
           <a:lstStyle/>
           <a:p>
             <a:r>
-              <a:rPr lang="en-US" altLang="da-DK" dirty="0">
+              <a:rPr lang="en-US" altLang="da-DK" b="1" dirty="0">
                 <a:latin typeface="Calibri" panose="020F0502020204030204" pitchFamily="34" charset="0"/>
               </a:rPr>
               <a:t>Discuss pros and cons of these typical solutions</a:t>
@@ -22747,6 +22747,55 @@
                       </p:childTnLst>
                     </p:cTn>
                   </p:par>
+                  <p:par>
+                    <p:cTn id="15" fill="hold">
+                      <p:stCondLst>
+                        <p:cond delay="indefinite"/>
+                      </p:stCondLst>
+                      <p:childTnLst>
+                        <p:par>
+                          <p:cTn id="16" fill="hold">
+                            <p:stCondLst>
+                              <p:cond delay="0"/>
+                            </p:stCondLst>
+                            <p:childTnLst>
+                              <p:par>
+                                <p:cTn id="17" presetID="1" presetClass="entr" presetSubtype="0" fill="hold" grpId="0" nodeType="clickEffect">
+                                  <p:stCondLst>
+                                    <p:cond delay="0"/>
+                                  </p:stCondLst>
+                                  <p:childTnLst>
+                                    <p:set>
+                                      <p:cBhvr>
+                                        <p:cTn id="18" dur="1" fill="hold">
+                                          <p:stCondLst>
+                                            <p:cond delay="0"/>
+                                          </p:stCondLst>
+                                        </p:cTn>
+                                        <p:tgtEl>
+                                          <p:spTgt spid="5">
+                                            <p:txEl>
+                                              <p:pRg st="0" end="0"/>
+                                            </p:txEl>
+                                          </p:spTgt>
+                                        </p:tgtEl>
+                                        <p:attrNameLst>
+                                          <p:attrName>style.visibility</p:attrName>
+                                        </p:attrNameLst>
+                                      </p:cBhvr>
+                                      <p:to>
+                                        <p:strVal val="visible"/>
+                                      </p:to>
+                                    </p:set>
+                                  </p:childTnLst>
+                                </p:cTn>
+                              </p:par>
+                            </p:childTnLst>
+                          </p:cTn>
+                        </p:par>
+                      </p:childTnLst>
+                    </p:cTn>
+                  </p:par>
                 </p:childTnLst>
               </p:cTn>
               <p:prevCondLst>
@@ -22769,6 +22818,7 @@
       </p:par>
     </p:tnLst>
     <p:bldLst>
+      <p:bldP spid="5" grpId="0" build="p"/>
       <p:bldP spid="3" grpId="0"/>
       <p:bldP spid="7" grpId="0"/>
     </p:bldLst>
@@ -22886,7 +22936,7 @@
           <a:p>
             <a:fld id="{B81908C6-3F4F-A34A-93FA-C1B5BAE4FDB1}" type="datetime1">
               <a:rPr lang="en-GB" smtClean="0"/>
-              <a:t>10/09/2025</a:t>
+              <a:t>08/09/2026</a:t>
             </a:fld>
             <a:endParaRPr lang="en-GB" dirty="0"/>
           </a:p>
@@ -23079,7 +23129,7 @@
           <a:p>
             <a:fld id="{B81908C6-3F4F-A34A-93FA-C1B5BAE4FDB1}" type="datetime1">
               <a:rPr lang="en-GB" smtClean="0"/>
-              <a:t>10/09/2025</a:t>
+              <a:t>08/09/2026</a:t>
             </a:fld>
             <a:endParaRPr lang="en-GB" dirty="0"/>
           </a:p>
@@ -23359,7 +23409,7 @@
           <a:p>
             <a:fld id="{B81908C6-3F4F-A34A-93FA-C1B5BAE4FDB1}" type="datetime1">
               <a:rPr lang="en-GB" smtClean="0"/>
-              <a:t>10/09/2025</a:t>
+              <a:t>08/09/2026</a:t>
             </a:fld>
             <a:endParaRPr lang="en-GB" dirty="0"/>
           </a:p>
@@ -23699,7 +23749,7 @@
           <a:p>
             <a:fld id="{B81908C6-3F4F-A34A-93FA-C1B5BAE4FDB1}" type="datetime1">
               <a:rPr lang="en-GB" smtClean="0"/>
-              <a:t>10/09/2025</a:t>
+              <a:t>08/09/2026</a:t>
             </a:fld>
             <a:endParaRPr lang="en-GB" dirty="0"/>
           </a:p>
@@ -24075,7 +24125,7 @@
           <a:p>
             <a:fld id="{B81908C6-3F4F-A34A-93FA-C1B5BAE4FDB1}" type="datetime1">
               <a:rPr lang="en-GB" smtClean="0"/>
-              <a:t>10/09/2025</a:t>
+              <a:t>08/09/2026</a:t>
             </a:fld>
             <a:endParaRPr lang="en-GB" dirty="0"/>
           </a:p>
@@ -24176,8 +24226,8 @@
           </a:xfrm>
           <a:prstGeom prst="wedgeRoundRectCallout">
             <a:avLst>
-              <a:gd name="adj1" fmla="val 86926"/>
-              <a:gd name="adj2" fmla="val -106602"/>
+              <a:gd name="adj1" fmla="val 84769"/>
+              <a:gd name="adj2" fmla="val -110223"/>
               <a:gd name="adj3" fmla="val 16667"/>
             </a:avLst>
           </a:prstGeom>
@@ -25565,19 +25615,19 @@
 </file>
 
 <file path=customXml/item1.xml><?xml version="1.0" encoding="utf-8"?>
+<TemplafySlideFormConfiguration><![CDATA[{"formFields":[],"formDataEntries":[]}]]></TemplafySlideFormConfiguration>
+</file>
+
+<file path=customXml/item10.xml><?xml version="1.0" encoding="utf-8"?>
+<TemplafySlideTemplateConfiguration><![CDATA[{"slideVersion":1,"isValidatorEnabled":false,"isLocked":false,"elementsMetadata":[],"slideId":"638344221285072627","enableDocumentContentUpdater":false,"version":"2.0"}]]></TemplafySlideTemplateConfiguration>
+</file>
+
+<file path=customXml/item11.xml><?xml version="1.0" encoding="utf-8"?>
 <TemplafySlideFormConfiguration><![CDATA[{"formFields":[{"required":true,"helpTexts":{},"spacing":{},"shareValue":false,"type":"datePicker","name":"Date","label":"Date"},{"required":false,"placeholder":"","lines":1,"helpTexts":{},"spacing":{},"shareValue":false,"type":"textBox","name":"EventOccasion","label":"Event / Occasion"}],"formDataEntries":[]}]]></TemplafySlideFormConfiguration>
 </file>
 
-<file path=customXml/item10.xml><?xml version="1.0" encoding="utf-8"?>
-<TemplafySlideFormConfiguration><![CDATA[{"formFields":[],"formDataEntries":[]}]]></TemplafySlideFormConfiguration>
-</file>
-
-<file path=customXml/item11.xml><?xml version="1.0" encoding="utf-8"?>
-<TemplafySlideTemplateConfiguration><![CDATA[{"slideVersion":1,"isValidatorEnabled":false,"isLocked":false,"elementsMetadata":[{"type":"shape","elementConfiguration":{"binding":"{{FormatDateTime(Form.Date, \"d. MMMM yyyy\")}}","visibility":"","type":"text","disableUpdates":false}},{"type":"shape","elementConfiguration":{"binding":"{{Form.EventOccasion}}","visibility":"","type":"text","disableUpdates":false}},{"type":"shape","elementConfiguration":{"binding":"{{UserProfile.Title}}","visibility":"","type":"text","disableUpdates":false}},{"type":"shape","elementConfiguration":{"binding":"{{UserProfile.Name}}","visibility":"","type":"text","disableUpdates":false}},{"type":"shape","elementConfiguration":{"inheritDimensions":"{{InheritDimensions.InheritNone}}","width":"4.61 cm","height":"1.55 cm","image":"{{UserProfile.UnitId.ExtraLogoRef.ImageRightAlignedNegRef.ImageFile}}","visibility":"","type":"image","disableUpdates":false}},{"type":"shape","elementConfiguration":{"binding":"{{UserProfile.UnitId.Logo2}}","visibility":"","type":"text","disableUpdates":false}},{"type":"shape","elementConfiguration":{"binding":"{{UserProfile.UnitId.Logo1PowerPoint}}","visibility":"","type":"text","disableUpdates":false}}],"slideId":"638344221284623770","enableDocumentContentUpdater":false,"version":"2.0"}]]></TemplafySlideTemplateConfiguration>
-</file>
-
 <file path=customXml/item12.xml><?xml version="1.0" encoding="utf-8"?>
-<TemplafySlideTemplateConfiguration><![CDATA[{"slideVersion":1,"isValidatorEnabled":false,"isLocked":false,"elementsMetadata":[],"slideId":"638344221285072627","enableDocumentContentUpdater":false,"version":"2.0"}]]></TemplafySlideTemplateConfiguration>
+<TemplafySlideTemplateConfiguration><![CDATA[{"slideVersion":1,"isValidatorEnabled":false,"isLocked":false,"elementsMetadata":[],"slideId":"638344221285055523","enableDocumentContentUpdater":false,"version":"2.0"}]]></TemplafySlideTemplateConfiguration>
 </file>
 
 <file path=customXml/item2.xml><?xml version="1.0" encoding="utf-8"?>
@@ -25585,23 +25635,23 @@
 </file>
 
 <file path=customXml/item3.xml><?xml version="1.0" encoding="utf-8"?>
-<TemplafySlideTemplateConfiguration><![CDATA[{"slideVersion":1,"isValidatorEnabled":false,"isLocked":false,"elementsMetadata":[{"type":"shape","elementConfiguration":{"binding":"{{UserProfile.UnitId.Logo1PowerPoint}}","visibility":"","type":"text","disableUpdates":false}}],"slideId":"638344221285170220","enableDocumentContentUpdater":false,"version":"2.0"}]]></TemplafySlideTemplateConfiguration>
+<TemplafySlideTemplateConfiguration><![CDATA[{"slideVersion":1,"isValidatorEnabled":false,"isLocked":false,"elementsMetadata":[{"type":"shape","elementConfiguration":{"binding":"{{FormatDateTime(Form.Date, \"d. MMMM yyyy\")}}","visibility":"","type":"text","disableUpdates":false}},{"type":"shape","elementConfiguration":{"binding":"{{Form.EventOccasion}}","visibility":"","type":"text","disableUpdates":false}},{"type":"shape","elementConfiguration":{"binding":"{{UserProfile.Title}}","visibility":"","type":"text","disableUpdates":false}},{"type":"shape","elementConfiguration":{"binding":"{{UserProfile.Name}}","visibility":"","type":"text","disableUpdates":false}},{"type":"shape","elementConfiguration":{"inheritDimensions":"{{InheritDimensions.InheritNone}}","width":"4.61 cm","height":"1.55 cm","image":"{{UserProfile.UnitId.ExtraLogoRef.ImageRightAlignedNegRef.ImageFile}}","visibility":"","type":"image","disableUpdates":false}},{"type":"shape","elementConfiguration":{"binding":"{{UserProfile.UnitId.Logo2}}","visibility":"","type":"text","disableUpdates":false}},{"type":"shape","elementConfiguration":{"binding":"{{UserProfile.UnitId.Logo1PowerPoint}}","visibility":"","type":"text","disableUpdates":false}}],"slideId":"638344221284623770","enableDocumentContentUpdater":false,"version":"2.0"}]]></TemplafySlideTemplateConfiguration>
 </file>
 
 <file path=customXml/item4.xml><?xml version="1.0" encoding="utf-8"?>
+<TemplafyFormConfiguration><![CDATA[{"formFields":[{"required":true,"helpTexts":{},"spacing":{},"shareValue":false,"type":"datePicker","name":"Date","label":"Date"},{"required":false,"placeholder":"","lines":1,"helpTexts":{},"spacing":{},"shareValue":false,"type":"textBox","name":"EventOccasion","label":"Event / Occasion"},{"distinct":false,"hideIfNoUserInteractionRequired":false,"required":false,"defaultValue":"Blå","autoSelectFirstOption":false,"helpTexts":{},"spacing":{},"shareValue":false,"type":"dropDown","dataSourceName":"ColorThemePowerPoint","dataSourceFieldName":"Name","name":"ChooseColorTheme","label":"Choose Color theme"}],"formDataEntries":[{"name":"Date","value":"ptInSCoS+zdybCpDtma1AQ=="},{"name":"EventOccasion","value":"9SuxJ2H9wxYbBHC7YHxa1w=="},{"name":"ChooseColorTheme","value":"XmRlVpWiose5Rf1eG6aJznCjkbXXnh6o3o1+21OmFqQ="}]}]]></TemplafyFormConfiguration>
+</file>
+
+<file path=customXml/item5.xml><?xml version="1.0" encoding="utf-8"?>
+<TemplafySlideFormConfiguration><![CDATA[{"formFields":[],"formDataEntries":[]}]]></TemplafySlideFormConfiguration>
+</file>
+
+<file path=customXml/item6.xml><?xml version="1.0" encoding="utf-8"?>
 <TemplafyTemplateConfiguration><![CDATA[{"elementsMetadata":[{"type":"shape","id":"cfb16d62-f424-4b05-bdc4-472a6934fced","elementConfiguration":{"binding":"{{FormatDateTime(Form.Date, \"d. MMMM yyyy\")}}","visibility":"","type":"text","disableUpdates":false}},{"type":"shape","id":"428eb784-b9af-4517-9e2e-6ff6d0acd562","elementConfiguration":{"binding":"{{Form.EventOccasion}}","visibility":"","type":"text","disableUpdates":false}},{"type":"shape","id":"129d852b-970f-4cd4-b072-993aa29ddf55","elementConfiguration":{"binding":"{{UserProfile.Title}}","visibility":"","type":"text","disableUpdates":false}},{"type":"shape","id":"d85cd4a2-0e75-4080-a857-f12869c869ed","elementConfiguration":{"binding":"{{UserProfile.Name}}","visibility":"","type":"text","disableUpdates":false}},{"type":"shape","id":"5b23b491-5d54-41f6-baeb-dc869ba03b37","elementConfiguration":{"inheritDimensions":"{{InheritDimensions.InheritNone}}","width":"4.61 cm","height":"1.55 cm","image":"{{UserProfile.UnitId.ExtraLogoRef.ImageRightAlignedRef.ImageFile}}","visibility":"","type":"image","disableUpdates":false}},{"type":"shape","id":"18db1068-4c6d-4ec0-86cf-47fa6b2593bd","elementConfiguration":{"binding":"{{UserProfile.UnitId.Logo2}}","visibility":"","type":"text","disableUpdates":false}},{"type":"shape","id":"746e9f11-92ba-4291-a8cc-2861a517d5e2","elementConfiguration":{"binding":"{{UserProfile.UnitId.Logo1PowerPoint}}","visibility":"","type":"text","disableUpdates":false}},{"type":"shape","id":"649ac06a-f9d2-41d0-9f8b-af29d75a1692","elementConfiguration":{"binding":"{{FormatDateTime(Form.Date, \"d. MMMM yyyy\")}}","visibility":"","type":"text","disableUpdates":false}},{"type":"shape","id":"26eb8480-b962-4476-ae45-f8b2e3817a24","elementConfiguration":{"binding":"{{Form.EventOccasion}}","visibility":"","type":"text","disableUpdates":false}},{"type":"shape","id":"83b83807-f32c-4213-864f-3a578b4ee360","elementConfiguration":{"inheritDimensions":"{{InheritDimensions.InheritNone}}","width":"4.61 cm","height":"1.55 cm","image":"{{UserProfile.UnitId.ExtraLogoRef.ImageRightAlignedNegRef.ImageFile}}","visibility":"","type":"image","disableUpdates":false}},{"type":"shape","id":"3eab1b86-8b44-4452-aea8-d11991fc5758","elementConfiguration":{"binding":"{{UserProfile.UnitId.Logo2}}","visibility":"","type":"text","disableUpdates":false}},{"type":"shape","id":"b0952b9b-ca2a-4412-bb0a-2e6f1d189999","elementConfiguration":{"binding":"{{UserProfile.UnitId.Logo1PowerPoint}}","visibility":"","type":"text","disableUpdates":false}},{"type":"shape","id":"0c1db09e-5d0d-491c-b49d-827568e79299","elementConfiguration":{"binding":"{{FormatDateTime(Form.Date, \"d. MMMM yyyy\")}}","visibility":"","type":"text","disableUpdates":false}},{"type":"shape","id":"cae1ecc3-91b3-4f5b-88ed-5860c672ac8a","elementConfiguration":{"binding":"{{Form.EventOccasion}}","visibility":"","type":"text","disableUpdates":false}},{"type":"shape","id":"fec7ae8a-b536-4bcb-8c29-11f99f4860d6","elementConfiguration":{"binding":"{{UserProfile.Name}}","visibility":"","type":"text","disableUpdates":false}},{"type":"shape","id":"5fc34ce1-1536-49c2-a17a-c8824404b886","elementConfiguration":{"inheritDimensions":"{{InheritDimensions.InheritNone}}","width":"4.61 cm","height":"1.55 cm","image":"{{UserProfile.UnitId.ExtraLogoRef.ImageRightAlignedNegRef.ImageFile}}","visibility":"","type":"image","disableUpdates":false}},{"type":"shape","id":"1ebc2c06-66b1-4da6-bb6d-bde871831410","elementConfiguration":{"binding":"{{UserProfile.UnitId.Logo2}}","visibility":"","type":"text","disableUpdates":false}},{"type":"shape","id":"b50437f8-2713-420a-a354-c271af15a597","elementConfiguration":{"binding":"{{UserProfile.UnitId.Logo1PowerPoint}}","visibility":"","type":"text","disableUpdates":false}},{"type":"shape","id":"16c4ec63-da0f-4e24-81bc-e42595263d83","elementConfiguration":{"binding":"{{UserProfile.UnitId.Logo1PowerPoint}}","visibility":"","type":"text","disableUpdates":false}},{"type":"shape","id":"a4b5cdf4-9238-4cda-ab1a-1252be352214","elementConfiguration":{"binding":"{{FormatDateTime(Form.Date, \"d. MMMM yyyy\")}}","visibility":"","type":"text","disableUpdates":false}},{"type":"shape","id":"138a166d-fede-44a5-8ecc-2804c9fc9e64","elementConfiguration":{"binding":"{{Form.EventOccasion}}","visibility":"","type":"text","disableUpdates":false}},{"type":"shape","id":"9c14bf20-ffed-462e-b8ea-8359c204e0ac","elementConfiguration":{"binding":"{{UserProfile.Title}}","visibility":"","type":"text","disableUpdates":false}},{"type":"shape","id":"231e2c89-d645-4e20-903e-bd18ca8212bf","elementConfiguration":{"binding":"{{UserProfile.Name}}","visibility":"","type":"text","disableUpdates":false}},{"type":"shape","id":"6af30e69-e885-4367-9065-327d13a5336c","elementConfiguration":{"inheritDimensions":"{{InheritDimensions.InheritNone}}","width":"4.61 cm","height":"1.55 cm","image":"{{UserProfile.UnitId.ExtraLogoRef.ImageRightAlignedNegRef.ImageFile}}","visibility":"","type":"image","disableUpdates":false}},{"type":"shape","id":"25b8be3e-6558-43c5-8fce-9d14eeb2375f","elementConfiguration":{"binding":"{{UserProfile.UnitId.Logo2}}","visibility":"","type":"text","disableUpdates":false}},{"type":"shape","id":"a1fdb61a-c788-4fc6-b2be-0fe2955e72c0","elementConfiguration":{"binding":"{{UserProfile.UnitId.Logo1PowerPoint}}","visibility":"","type":"text","disableUpdates":false}}],"transformationConfigurations":[{"language":"{{DocumentLanguage}}","disableUpdates":false,"type":"proofingLanguage"},{"colorTheme":"{{Form.ChooseColorTheme.ColorThemeRef.ColorTheme}}","disableUpdates":false,"originalColorThemeXml":"<a:clrScheme name=\"01 AU Blue\" xmlns:a=\"http://schemas.openxmlformats.org/drawingml/2006/main\"><a:dk1><a:srgbClr val=\"000000\" /></a:dk1><a:lt1><a:srgbClr val=\"FFFFFF\" /></a:lt1><a:dk2><a:srgbClr val=\"002546\" /></a:dk2><a:lt2><a:srgbClr val=\"002546\" /></a:lt2><a:accent1><a:srgbClr val=\"0A1449\" /></a:accent1><a:accent2><a:srgbClr val=\"183D83\" /></a:accent2><a:accent3><a:srgbClr val=\"87D1F4\" /></a:accent3><a:accent4><a:srgbClr val=\"33525F\" /></a:accent4><a:accent5><a:srgbClr val=\"548195\" /></a:accent5><a:accent6><a:srgbClr val=\"C6C6C6\" /></a:accent6><a:hlink><a:srgbClr val=\"03428E\" /></a:hlink><a:folHlink><a:srgbClr val=\"03428E\" /></a:folHlink></a:clrScheme>","type":"colorTheme"}],"templateName":"PowerPoint skabelon","templateDescription":"PowerPoint template 16:9 (convertible to 16:10 or 4:3)","enableDocumentContentUpdater":true,"version":"2.0"}]]></TemplafyTemplateConfiguration>
 </file>
 
-<file path=customXml/item5.xml><?xml version="1.0" encoding="utf-8"?>
-<TemplafyFormConfiguration><![CDATA[{"formFields":[{"required":true,"helpTexts":{},"spacing":{},"shareValue":false,"type":"datePicker","name":"Date","label":"Date"},{"required":false,"placeholder":"","lines":1,"helpTexts":{},"spacing":{},"shareValue":false,"type":"textBox","name":"EventOccasion","label":"Event / Occasion"},{"distinct":false,"hideIfNoUserInteractionRequired":false,"required":false,"defaultValue":"Blå","autoSelectFirstOption":false,"helpTexts":{},"spacing":{},"shareValue":false,"type":"dropDown","dataSourceName":"ColorThemePowerPoint","dataSourceFieldName":"Name","name":"ChooseColorTheme","label":"Choose Color theme"}],"formDataEntries":[{"name":"Date","value":"ptInSCoS+zdybCpDtma1AQ=="},{"name":"EventOccasion","value":"9SuxJ2H9wxYbBHC7YHxa1w=="},{"name":"ChooseColorTheme","value":"XmRlVpWiose5Rf1eG6aJznCjkbXXnh6o3o1+21OmFqQ="}]}]]></TemplafyFormConfiguration>
-</file>
-
-<file path=customXml/item6.xml><?xml version="1.0" encoding="utf-8"?>
-<TemplafySlideTemplateConfiguration><![CDATA[{"slideVersion":1,"isValidatorEnabled":false,"isLocked":false,"elementsMetadata":[],"slideId":"638344221285055523","enableDocumentContentUpdater":false,"version":"2.0"}]]></TemplafySlideTemplateConfiguration>
-</file>
-
 <file path=customXml/item7.xml><?xml version="1.0" encoding="utf-8"?>
-<TemplafySlideFormConfiguration><![CDATA[{"formFields":[],"formDataEntries":[]}]]></TemplafySlideFormConfiguration>
+<TemplafySlideTemplateConfiguration><![CDATA[{"slideVersion":1,"isValidatorEnabled":false,"isLocked":false,"elementsMetadata":[],"slideId":"638344221285091994","enableDocumentContentUpdater":false,"version":"2.0"}]]></TemplafySlideTemplateConfiguration>
 </file>
 
 <file path=customXml/item8.xml><?xml version="1.0" encoding="utf-8"?>
@@ -25609,29 +25659,29 @@
 </file>
 
 <file path=customXml/item9.xml><?xml version="1.0" encoding="utf-8"?>
-<TemplafySlideTemplateConfiguration><![CDATA[{"slideVersion":1,"isValidatorEnabled":false,"isLocked":false,"elementsMetadata":[],"slideId":"638344221285091994","enableDocumentContentUpdater":false,"version":"2.0"}]]></TemplafySlideTemplateConfiguration>
+<TemplafySlideTemplateConfiguration><![CDATA[{"slideVersion":1,"isValidatorEnabled":false,"isLocked":false,"elementsMetadata":[{"type":"shape","elementConfiguration":{"binding":"{{UserProfile.UnitId.Logo1PowerPoint}}","visibility":"","type":"text","disableUpdates":false}}],"slideId":"638344221285170220","enableDocumentContentUpdater":false,"version":"2.0"}]]></TemplafySlideTemplateConfiguration>
 </file>
 
 <file path=customXml/itemProps1.xml><?xml version="1.0" encoding="utf-8"?>
+<ds:datastoreItem xmlns:ds="http://schemas.openxmlformats.org/officeDocument/2006/customXml" ds:itemID="{F6BDCACD-D9F5-4F4E-8192-10C1008EFFE8}">
+  <ds:schemaRefs/>
+</ds:datastoreItem>
+</file>
+
+<file path=customXml/itemProps10.xml><?xml version="1.0" encoding="utf-8"?>
+<ds:datastoreItem xmlns:ds="http://schemas.openxmlformats.org/officeDocument/2006/customXml" ds:itemID="{3643F53D-29F6-46FD-9FF1-B40DF29295C1}">
+  <ds:schemaRefs/>
+</ds:datastoreItem>
+</file>
+
+<file path=customXml/itemProps11.xml><?xml version="1.0" encoding="utf-8"?>
 <ds:datastoreItem xmlns:ds="http://schemas.openxmlformats.org/officeDocument/2006/customXml" ds:itemID="{7E04581C-D7FD-4482-805D-038A22FDA87B}">
   <ds:schemaRefs/>
 </ds:datastoreItem>
 </file>
 
-<file path=customXml/itemProps10.xml><?xml version="1.0" encoding="utf-8"?>
-<ds:datastoreItem xmlns:ds="http://schemas.openxmlformats.org/officeDocument/2006/customXml" ds:itemID="{065744AD-6466-4C46-AE6F-83D8FBC1C1CF}">
-  <ds:schemaRefs/>
-</ds:datastoreItem>
-</file>
-
-<file path=customXml/itemProps11.xml><?xml version="1.0" encoding="utf-8"?>
-<ds:datastoreItem xmlns:ds="http://schemas.openxmlformats.org/officeDocument/2006/customXml" ds:itemID="{B2CA2D4C-0385-4D99-AB8D-7792A88C817E}">
-  <ds:schemaRefs/>
-</ds:datastoreItem>
-</file>
-
 <file path=customXml/itemProps12.xml><?xml version="1.0" encoding="utf-8"?>
-<ds:datastoreItem xmlns:ds="http://schemas.openxmlformats.org/officeDocument/2006/customXml" ds:itemID="{3643F53D-29F6-46FD-9FF1-B40DF29295C1}">
+<ds:datastoreItem xmlns:ds="http://schemas.openxmlformats.org/officeDocument/2006/customXml" ds:itemID="{3711B4B0-0534-4D87-9554-EE0E3A45C434}">
   <ds:schemaRefs/>
 </ds:datastoreItem>
 </file>
@@ -25643,31 +25693,31 @@
 </file>
 
 <file path=customXml/itemProps3.xml><?xml version="1.0" encoding="utf-8"?>
-<ds:datastoreItem xmlns:ds="http://schemas.openxmlformats.org/officeDocument/2006/customXml" ds:itemID="{F6929CAD-9C4B-4C57-B5A5-181E7E3C58CB}">
+<ds:datastoreItem xmlns:ds="http://schemas.openxmlformats.org/officeDocument/2006/customXml" ds:itemID="{B2CA2D4C-0385-4D99-AB8D-7792A88C817E}">
   <ds:schemaRefs/>
 </ds:datastoreItem>
 </file>
 
 <file path=customXml/itemProps4.xml><?xml version="1.0" encoding="utf-8"?>
+<ds:datastoreItem xmlns:ds="http://schemas.openxmlformats.org/officeDocument/2006/customXml" ds:itemID="{7DA86E9B-4135-4144-9EBF-FD9F3AFEC348}">
+  <ds:schemaRefs/>
+</ds:datastoreItem>
+</file>
+
+<file path=customXml/itemProps5.xml><?xml version="1.0" encoding="utf-8"?>
+<ds:datastoreItem xmlns:ds="http://schemas.openxmlformats.org/officeDocument/2006/customXml" ds:itemID="{065744AD-6466-4C46-AE6F-83D8FBC1C1CF}">
+  <ds:schemaRefs/>
+</ds:datastoreItem>
+</file>
+
+<file path=customXml/itemProps6.xml><?xml version="1.0" encoding="utf-8"?>
 <ds:datastoreItem xmlns:ds="http://schemas.openxmlformats.org/officeDocument/2006/customXml" ds:itemID="{AFC86994-F0FF-421B-841D-005E37E2CB9C}">
   <ds:schemaRefs/>
 </ds:datastoreItem>
 </file>
 
-<file path=customXml/itemProps5.xml><?xml version="1.0" encoding="utf-8"?>
-<ds:datastoreItem xmlns:ds="http://schemas.openxmlformats.org/officeDocument/2006/customXml" ds:itemID="{7DA86E9B-4135-4144-9EBF-FD9F3AFEC348}">
-  <ds:schemaRefs/>
-</ds:datastoreItem>
-</file>
-
-<file path=customXml/itemProps6.xml><?xml version="1.0" encoding="utf-8"?>
-<ds:datastoreItem xmlns:ds="http://schemas.openxmlformats.org/officeDocument/2006/customXml" ds:itemID="{3711B4B0-0534-4D87-9554-EE0E3A45C434}">
-  <ds:schemaRefs/>
-</ds:datastoreItem>
-</file>
-
 <file path=customXml/itemProps7.xml><?xml version="1.0" encoding="utf-8"?>
-<ds:datastoreItem xmlns:ds="http://schemas.openxmlformats.org/officeDocument/2006/customXml" ds:itemID="{F6BDCACD-D9F5-4F4E-8192-10C1008EFFE8}">
+<ds:datastoreItem xmlns:ds="http://schemas.openxmlformats.org/officeDocument/2006/customXml" ds:itemID="{D8EFAE61-AC68-4E39-9D00-2ECB552AF7C0}">
   <ds:schemaRefs/>
 </ds:datastoreItem>
 </file>
@@ -25679,7 +25729,7 @@
 </file>
 
 <file path=customXml/itemProps9.xml><?xml version="1.0" encoding="utf-8"?>
-<ds:datastoreItem xmlns:ds="http://schemas.openxmlformats.org/officeDocument/2006/customXml" ds:itemID="{D8EFAE61-AC68-4E39-9D00-2ECB552AF7C0}">
+<ds:datastoreItem xmlns:ds="http://schemas.openxmlformats.org/officeDocument/2006/customXml" ds:itemID="{F6929CAD-9C4B-4C57-B5A5-181E7E3C58CB}">
   <ds:schemaRefs/>
 </ds:datastoreItem>
 </file>
</xml_diff>